<commit_message>
pdfs and report name changes
</commit_message>
<xml_diff>
--- a/reports/Presentation.pptx
+++ b/reports/Presentation.pptx
@@ -3321,6 +3321,45 @@
       </p:sp>
       <p:sp>
         <p:nvSpPr>
+          <p:cNvPr id="8" name="TextBox 7"/>
+          <p:cNvSpPr txBox="1"/>
+          <p:nvPr/>
+        </p:nvSpPr>
+        <p:spPr>
+          <a:xfrm>
+            <a:off x="822960" y="5851200"/>
+            <a:ext cx="10058400" cy="365760"/>
+          </a:xfrm>
+          <a:prstGeom prst="rect">
+            <a:avLst/>
+          </a:prstGeom>
+          <a:noFill/>
+        </p:spPr>
+        <p:txBody>
+          <a:bodyPr wrap="square" anchor="t">
+            <a:spAutoFit/>
+          </a:bodyPr>
+          <a:lstStyle/>
+          <a:p>
+            <a:pPr algn="l">
+              <a:lnSpc>
+                <a:spcPct val="100000"/>
+              </a:lnSpc>
+            </a:pPr>
+            <a:r>
+              <a:rPr sz="1400" b="1" i="0">
+                <a:solidFill>
+                  <a:srgbClr val="CCCCCC"/>
+                </a:solidFill>
+                <a:latin typeface="Calibri"/>
+              </a:rPr>
+              <a:t>Ashutosh Singh (23117033)    ·    Ayush (23117036)</a:t>
+            </a:r>
+          </a:p>
+        </p:txBody>
+      </p:sp>
+      <p:sp>
+        <p:nvSpPr>
           <p:cNvPr id="7" name="TextBox 6"/>
           <p:cNvSpPr txBox="1"/>
           <p:nvPr/>
@@ -3574,7 +3613,7 @@
                   <a:srgbClr val="E50914"/>
                 </a:solidFill>
               </a:rPr>
-              <a:t>•  </a:t>
+              <a:t xml:space="preserve">•  </a:t>
             </a:r>
             <a:r>
               <a:rPr sz="1500" b="1">
@@ -3592,7 +3631,7 @@
                 </a:solidFill>
                 <a:latin typeface="Calibri"/>
               </a:rPr>
-              <a:t> → measured by RMSE</a:t>
+              <a:t xml:space="preserve"> → measured by RMSE</a:t>
             </a:r>
           </a:p>
           <a:p>
@@ -3610,7 +3649,7 @@
                   <a:srgbClr val="E50914"/>
                 </a:solidFill>
               </a:rPr>
-              <a:t>•  </a:t>
+              <a:t xml:space="preserve">•  </a:t>
             </a:r>
             <a:r>
               <a:rPr sz="1500" b="1">
@@ -3628,7 +3667,7 @@
                 </a:solidFill>
                 <a:latin typeface="Calibri"/>
               </a:rPr>
-              <a:t> → measured by MAP@10</a:t>
+              <a:t xml:space="preserve"> → measured by MAP@10</a:t>
             </a:r>
           </a:p>
         </p:txBody>
@@ -4661,7 +4700,7 @@
                   <a:srgbClr val="E50914"/>
                 </a:solidFill>
               </a:rPr>
-              <a:t>•  </a:t>
+              <a:t xml:space="preserve">•  </a:t>
             </a:r>
             <a:r>
               <a:rPr sz="1500" b="1">
@@ -4679,7 +4718,7 @@
                 </a:solidFill>
                 <a:latin typeface="Calibri"/>
               </a:rPr>
-              <a:t> — ~85% of ratings are 3–5★; a model must beat the "predict the mean" trap.</a:t>
+              <a:t xml:space="preserve"> — ~85% of ratings are 3–5★; a model must beat the "predict the mean" trap.</a:t>
             </a:r>
           </a:p>
           <a:p>
@@ -4697,7 +4736,7 @@
                   <a:srgbClr val="E50914"/>
                 </a:solidFill>
               </a:rPr>
-              <a:t>•  </a:t>
+              <a:t xml:space="preserve">•  </a:t>
             </a:r>
             <a:r>
               <a:rPr sz="1500" b="1">
@@ -4715,7 +4754,7 @@
                 </a:solidFill>
                 <a:latin typeface="Calibri"/>
               </a:rPr>
-              <a:t> — a few blockbusters dominate, making popularity a deceptively strong baseline.</a:t>
+              <a:t xml:space="preserve"> — a few blockbusters dominate, making popularity a deceptively strong baseline.</a:t>
             </a:r>
           </a:p>
           <a:p>
@@ -4733,7 +4772,7 @@
                   <a:srgbClr val="E50914"/>
                 </a:solidFill>
               </a:rPr>
-              <a:t>•  </a:t>
+              <a:t xml:space="preserve">•  </a:t>
             </a:r>
             <a:r>
               <a:rPr sz="1500" b="1">
@@ -4751,7 +4790,7 @@
                 </a:solidFill>
                 <a:latin typeface="Calibri"/>
               </a:rPr>
-              <a:t> — rating volume rises sharply, so we use a temporal (past→future) split, not random.</a:t>
+              <a:t xml:space="preserve"> — rating volume rises sharply, so we use a temporal (past→future) split, not random.</a:t>
             </a:r>
           </a:p>
         </p:txBody>
@@ -5612,7 +5651,7 @@
                 </a:solidFill>
                 <a:latin typeface="Calibri"/>
               </a:rPr>
-              <a:t>Evaluation protocol.  </a:t>
+              <a:t xml:space="preserve">Evaluation protocol.  </a:t>
             </a:r>
             <a:r>
               <a:rPr sz="1400">
@@ -7243,7 +7282,7 @@
                   <a:srgbClr val="E50914"/>
                 </a:solidFill>
               </a:rPr>
-              <a:t>•  </a:t>
+              <a:t xml:space="preserve">•  </a:t>
             </a:r>
             <a:r>
               <a:rPr sz="1500" b="1">
@@ -7261,7 +7300,7 @@
                 </a:solidFill>
                 <a:latin typeface="Calibri"/>
               </a:rPr>
-              <a:t> wins hit-rate — but covers &lt;1% of the catalog.</a:t>
+              <a:t xml:space="preserve"> wins hit-rate — but covers &lt;1% of the catalog.</a:t>
             </a:r>
           </a:p>
           <a:p>
@@ -7279,7 +7318,7 @@
                   <a:srgbClr val="E50914"/>
                 </a:solidFill>
               </a:rPr>
-              <a:t>•  </a:t>
+              <a:t xml:space="preserve">•  </a:t>
             </a:r>
             <a:r>
               <a:rPr sz="1500" b="1">
@@ -7297,7 +7336,7 @@
                 </a:solidFill>
                 <a:latin typeface="Calibri"/>
               </a:rPr>
-              <a:t> personalizes at near-equal quality.</a:t>
+              <a:t xml:space="preserve"> personalizes at near-equal quality.</a:t>
             </a:r>
           </a:p>
           <a:p>
@@ -7315,7 +7354,7 @@
                   <a:srgbClr val="E50914"/>
                 </a:solidFill>
               </a:rPr>
-              <a:t>•  </a:t>
+              <a:t xml:space="preserve">•  </a:t>
             </a:r>
             <a:r>
               <a:rPr sz="1500" b="1">
@@ -7333,7 +7372,7 @@
                 </a:solidFill>
                 <a:latin typeface="Calibri"/>
               </a:rPr>
-              <a:t> reaches 61% coverage — far more diverse — at an accuracy cost.</a:t>
+              <a:t xml:space="preserve"> reaches 61% coverage — far more diverse — at an accuracy cost.</a:t>
             </a:r>
           </a:p>
         </p:txBody>
@@ -7386,7 +7425,7 @@
                 </a:solidFill>
                 <a:latin typeface="Calibri"/>
               </a:rPr>
-              <a:t>No single model wins every metric. </a:t>
+              <a:t xml:space="preserve">No single model wins every metric. </a:t>
             </a:r>
             <a:r>
               <a:rPr sz="1400">
@@ -8319,7 +8358,7 @@
                 </a:solidFill>
                 <a:latin typeface="Calibri"/>
               </a:rPr>
-              <a:t>Explainability.  </a:t>
+              <a:t xml:space="preserve">Explainability.  </a:t>
             </a:r>
             <a:r>
               <a:rPr sz="1400">
@@ -8600,7 +8639,7 @@
                   <a:srgbClr val="E50914"/>
                 </a:solidFill>
               </a:rPr>
-              <a:t>•  </a:t>
+              <a:t xml:space="preserve">•  </a:t>
             </a:r>
             <a:r>
               <a:rPr sz="1500" b="0">
@@ -8627,7 +8666,7 @@
                   <a:srgbClr val="E50914"/>
                 </a:solidFill>
               </a:rPr>
-              <a:t>•  </a:t>
+              <a:t xml:space="preserve">•  </a:t>
             </a:r>
             <a:r>
               <a:rPr sz="1500" b="0">
@@ -8654,7 +8693,7 @@
                   <a:srgbClr val="E50914"/>
                 </a:solidFill>
               </a:rPr>
-              <a:t>•  </a:t>
+              <a:t xml:space="preserve">•  </a:t>
             </a:r>
             <a:r>
               <a:rPr sz="1500" b="0">
@@ -8681,7 +8720,7 @@
                   <a:srgbClr val="E50914"/>
                 </a:solidFill>
               </a:rPr>
-              <a:t>•  </a:t>
+              <a:t xml:space="preserve">•  </a:t>
             </a:r>
             <a:r>
               <a:rPr sz="1500" b="0">
@@ -8770,7 +8809,7 @@
                   <a:srgbClr val="E50914"/>
                 </a:solidFill>
               </a:rPr>
-              <a:t>•  </a:t>
+              <a:t xml:space="preserve">•  </a:t>
             </a:r>
             <a:r>
               <a:rPr sz="1500" b="0">
@@ -8797,7 +8836,7 @@
                   <a:srgbClr val="E50914"/>
                 </a:solidFill>
               </a:rPr>
-              <a:t>•  </a:t>
+              <a:t xml:space="preserve">•  </a:t>
             </a:r>
             <a:r>
               <a:rPr sz="1500" b="0">
@@ -8824,7 +8863,7 @@
                   <a:srgbClr val="E50914"/>
                 </a:solidFill>
               </a:rPr>
-              <a:t>•  </a:t>
+              <a:t xml:space="preserve">•  </a:t>
             </a:r>
             <a:r>
               <a:rPr sz="1500" b="0">
@@ -8851,7 +8890,7 @@
                   <a:srgbClr val="E50914"/>
                 </a:solidFill>
               </a:rPr>
-              <a:t>•  </a:t>
+              <a:t xml:space="preserve">•  </a:t>
             </a:r>
             <a:r>
               <a:rPr sz="1500" b="0">

</xml_diff>